<commit_message>
lecture ready(0820) : Ts_Type
</commit_message>
<xml_diff>
--- a/material/[SeSAC_YDP_6] 32_1_TypeScript.pptx
+++ b/material/[SeSAC_YDP_6] 32_1_TypeScript.pptx
@@ -223,7 +223,7 @@
           <a:p>
             <a:fld id="{86F0F02C-F923-483B-B7AF-E4D1E093BA0E}" type="datetimeFigureOut">
               <a:rPr lang="ko-KR" altLang="en-US" smtClean="0"/>
-              <a:t>2024-08-19</a:t>
+              <a:t>2024-08-20</a:t>
             </a:fld>
             <a:endParaRPr lang="ko-KR" altLang="en-US"/>
           </a:p>
@@ -1858,6 +1858,71 @@
           <a:bodyPr/>
           <a:lstStyle/>
           <a:p>
+            <a:r>
+              <a:rPr lang="ko-KR" altLang="en-US" dirty="0"/>
+              <a:t>객체의 구조를 정의하는 데 사용하는 매우 중요한 기능</a:t>
+            </a:r>
+            <a:r>
+              <a:rPr lang="en-US" altLang="ko-KR" dirty="0"/>
+              <a:t>!</a:t>
+            </a:r>
+          </a:p>
+          <a:p>
+            <a:r>
+              <a:rPr lang="ko-KR" altLang="en-US" dirty="0"/>
+              <a:t>객체가 어떤 속성과 메서드를 가져야 하는지를 미리 지정할 수 있음</a:t>
+            </a:r>
+            <a:r>
+              <a:rPr lang="en-US" altLang="ko-KR" dirty="0"/>
+              <a:t>.</a:t>
+            </a:r>
+          </a:p>
+          <a:p>
+            <a:r>
+              <a:rPr lang="ko-KR" altLang="en-US" dirty="0"/>
+              <a:t>이로 인해 코드의 가독성과 유지보수성이 높아짐</a:t>
+            </a:r>
+            <a:r>
+              <a:rPr lang="en-US" altLang="ko-KR" dirty="0"/>
+              <a:t>!</a:t>
+            </a:r>
+          </a:p>
+          <a:p>
+            <a:endParaRPr lang="en-US" altLang="ko-KR" dirty="0"/>
+          </a:p>
+          <a:p>
+            <a:r>
+              <a:rPr lang="ko-KR" altLang="en-US" dirty="0"/>
+              <a:t>객체가 특정 </a:t>
+            </a:r>
+            <a:r>
+              <a:rPr lang="en-US" altLang="ko-KR" dirty="0"/>
+              <a:t>‘interface’</a:t>
+            </a:r>
+            <a:r>
+              <a:rPr lang="ko-KR" altLang="en-US" dirty="0"/>
+              <a:t>를</a:t>
+            </a:r>
+            <a:r>
+              <a:rPr lang="en-US" altLang="ko-KR" dirty="0"/>
+              <a:t> </a:t>
+            </a:r>
+            <a:r>
+              <a:rPr lang="ko-KR" altLang="en-US" dirty="0"/>
+              <a:t>구현해야 한다는 것은 그 객체가 </a:t>
+            </a:r>
+            <a:r>
+              <a:rPr lang="en-US" altLang="ko-KR" dirty="0"/>
+              <a:t>‘interface’</a:t>
+            </a:r>
+            <a:r>
+              <a:rPr lang="ko-KR" altLang="en-US" dirty="0"/>
+              <a:t>에 정의된 모든 속성과 메서드를 가져야 한다는 의미</a:t>
+            </a:r>
+            <a:r>
+              <a:rPr lang="en-US" altLang="ko-KR" dirty="0"/>
+              <a:t>!</a:t>
+            </a:r>
             <a:endParaRPr lang="ko-KR" altLang="en-US" dirty="0"/>
           </a:p>
         </p:txBody>
@@ -10436,7 +10501,7 @@
           <a:p>
             <a:fld id="{0F78D9C4-20C1-4B15-A116-16DC77AD9A1E}" type="datetime1">
               <a:rPr lang="ko-KR" altLang="en-US" smtClean="0"/>
-              <a:t>2024-08-19</a:t>
+              <a:t>2024-08-20</a:t>
             </a:fld>
             <a:endParaRPr lang="ko-KR" altLang="en-US"/>
           </a:p>
@@ -12896,6 +12961,58 @@
               <a:latin typeface="메이플스토리" panose="02000300000000000000" pitchFamily="2" charset="-127"/>
               <a:ea typeface="메이플스토리" panose="02000300000000000000" pitchFamily="2" charset="-127"/>
             </a:endParaRPr>
+          </a:p>
+        </p:txBody>
+      </p:sp>
+      <p:sp>
+        <p:nvSpPr>
+          <p:cNvPr id="4" name="직사각형 3">
+            <a:extLst>
+              <a:ext uri="{FF2B5EF4-FFF2-40B4-BE49-F238E27FC236}">
+                <a16:creationId xmlns:a16="http://schemas.microsoft.com/office/drawing/2014/main" id="{7EA6C3E9-3A86-9011-8681-DCCDEF145879}"/>
+              </a:ext>
+            </a:extLst>
+          </p:cNvPr>
+          <p:cNvSpPr/>
+          <p:nvPr/>
+        </p:nvSpPr>
+        <p:spPr>
+          <a:xfrm>
+            <a:off x="2038531" y="2259561"/>
+            <a:ext cx="1256461" cy="349632"/>
+          </a:xfrm>
+          <a:prstGeom prst="rect">
+            <a:avLst/>
+          </a:prstGeom>
+          <a:noFill/>
+          <a:ln w="28575">
+            <a:solidFill>
+              <a:srgbClr val="FF0000"/>
+            </a:solidFill>
+          </a:ln>
+        </p:spPr>
+        <p:style>
+          <a:lnRef idx="2">
+            <a:schemeClr val="accent1">
+              <a:shade val="15000"/>
+            </a:schemeClr>
+          </a:lnRef>
+          <a:fillRef idx="1">
+            <a:schemeClr val="accent1"/>
+          </a:fillRef>
+          <a:effectRef idx="0">
+            <a:schemeClr val="accent1"/>
+          </a:effectRef>
+          <a:fontRef idx="minor">
+            <a:schemeClr val="lt1"/>
+          </a:fontRef>
+        </p:style>
+        <p:txBody>
+          <a:bodyPr rtlCol="0" anchor="ctr"/>
+          <a:lstStyle/>
+          <a:p>
+            <a:pPr algn="ctr"/>
+            <a:endParaRPr lang="ko-KR" altLang="en-US"/>
           </a:p>
         </p:txBody>
       </p:sp>
@@ -13458,7 +13575,7 @@
           <a:p>
             <a:fld id="{0F78D9C4-20C1-4B15-A116-16DC77AD9A1E}" type="datetime1">
               <a:rPr lang="ko-KR" altLang="en-US" smtClean="0"/>
-              <a:t>2024-08-19</a:t>
+              <a:t>2024-08-20</a:t>
             </a:fld>
             <a:endParaRPr lang="ko-KR" altLang="en-US"/>
           </a:p>

</xml_diff>

<commit_message>
lecture ready (0820) : TS_generic
</commit_message>
<xml_diff>
--- a/material/[SeSAC_YDP_6] 32_1_TypeScript.pptx
+++ b/material/[SeSAC_YDP_6] 32_1_TypeScript.pptx
@@ -2110,6 +2110,90 @@
 </file>
 
 <file path=ppt/notesSlides/notesSlide20.xml><?xml version="1.0" encoding="utf-8"?>
+<p:notes xmlns:a="http://schemas.openxmlformats.org/drawingml/2006/main" xmlns:r="http://schemas.openxmlformats.org/officeDocument/2006/relationships" xmlns:p="http://schemas.openxmlformats.org/presentationml/2006/main">
+  <p:cSld>
+    <p:spTree>
+      <p:nvGrpSpPr>
+        <p:cNvPr id="1" name=""/>
+        <p:cNvGrpSpPr/>
+        <p:nvPr/>
+      </p:nvGrpSpPr>
+      <p:grpSpPr>
+        <a:xfrm>
+          <a:off x="0" y="0"/>
+          <a:ext cx="0" cy="0"/>
+          <a:chOff x="0" y="0"/>
+          <a:chExt cx="0" cy="0"/>
+        </a:xfrm>
+      </p:grpSpPr>
+      <p:sp>
+        <p:nvSpPr>
+          <p:cNvPr id="2" name="슬라이드 이미지 개체 틀 1"/>
+          <p:cNvSpPr>
+            <a:spLocks noGrp="1" noRot="1" noChangeAspect="1"/>
+          </p:cNvSpPr>
+          <p:nvPr>
+            <p:ph type="sldImg"/>
+          </p:nvPr>
+        </p:nvSpPr>
+        <p:spPr/>
+      </p:sp>
+      <p:sp>
+        <p:nvSpPr>
+          <p:cNvPr id="3" name="슬라이드 노트 개체 틀 2"/>
+          <p:cNvSpPr>
+            <a:spLocks noGrp="1"/>
+          </p:cNvSpPr>
+          <p:nvPr>
+            <p:ph type="body" idx="1"/>
+          </p:nvPr>
+        </p:nvSpPr>
+        <p:spPr/>
+        <p:txBody>
+          <a:bodyPr/>
+          <a:lstStyle/>
+          <a:p>
+            <a:endParaRPr lang="ko-KR" altLang="en-US" dirty="0"/>
+          </a:p>
+        </p:txBody>
+      </p:sp>
+      <p:sp>
+        <p:nvSpPr>
+          <p:cNvPr id="4" name="슬라이드 번호 개체 틀 3"/>
+          <p:cNvSpPr>
+            <a:spLocks noGrp="1"/>
+          </p:cNvSpPr>
+          <p:nvPr>
+            <p:ph type="sldNum" sz="quarter" idx="10"/>
+          </p:nvPr>
+        </p:nvSpPr>
+        <p:spPr/>
+        <p:txBody>
+          <a:bodyPr/>
+          <a:lstStyle/>
+          <a:p>
+            <a:fld id="{7B288C33-55A0-4375-B4B0-E8B5C9E6A8CF}" type="slidenum">
+              <a:rPr lang="ko-KR" altLang="en-US" smtClean="0"/>
+              <a:t>23</a:t>
+            </a:fld>
+            <a:endParaRPr lang="ko-KR" altLang="en-US"/>
+          </a:p>
+        </p:txBody>
+      </p:sp>
+    </p:spTree>
+    <p:extLst>
+      <p:ext uri="{BB962C8B-B14F-4D97-AF65-F5344CB8AC3E}">
+        <p14:creationId xmlns:p14="http://schemas.microsoft.com/office/powerpoint/2010/main" val="3869724381"/>
+      </p:ext>
+    </p:extLst>
+  </p:cSld>
+  <p:clrMapOvr>
+    <a:masterClrMapping/>
+  </p:clrMapOvr>
+</p:notes>
+</file>
+
+<file path=ppt/notesSlides/notesSlide21.xml><?xml version="1.0" encoding="utf-8"?>
 <p:notes xmlns:a="http://schemas.openxmlformats.org/drawingml/2006/main" xmlns:r="http://schemas.openxmlformats.org/officeDocument/2006/relationships" xmlns:p="http://schemas.openxmlformats.org/presentationml/2006/main">
   <p:cSld>
     <p:spTree>
@@ -7988,6 +8072,16 @@
             </a:endParaRPr>
           </a:p>
           <a:p>
+            <a:r>
+              <a:rPr lang="en-US" altLang="ko-KR" b="0" dirty="0">
+                <a:solidFill>
+                  <a:srgbClr val="A9B1D6"/>
+                </a:solidFill>
+                <a:effectLst/>
+                <a:latin typeface="Consolas" panose="020B0609020204030204" pitchFamily="49" charset="0"/>
+              </a:rPr>
+              <a:t/>
+            </a:r>
             <a:br>
               <a:rPr lang="en-US" altLang="ko-KR" b="0" dirty="0">
                 <a:solidFill>
@@ -10845,6 +10939,15 @@
               </a:rPr>
               <a:t>강의 클릭</a:t>
             </a:r>
+            <a:r>
+              <a:rPr lang="en-US" altLang="ko-KR" dirty="0">
+                <a:solidFill>
+                  <a:srgbClr val="212529"/>
+                </a:solidFill>
+                <a:latin typeface="+mn-ea"/>
+              </a:rPr>
+              <a:t/>
+            </a:r>
             <a:br>
               <a:rPr lang="en-US" altLang="ko-KR" dirty="0">
                 <a:solidFill>
@@ -12846,6 +12949,13 @@
               </a:rPr>
               <a:t>되는 것</a:t>
             </a:r>
+            <a:r>
+              <a:rPr lang="en-US" altLang="ko-KR" dirty="0">
+                <a:latin typeface="메이플스토리" panose="02000300000000000000" pitchFamily="2" charset="-127"/>
+                <a:ea typeface="메이플스토리" panose="02000300000000000000" pitchFamily="2" charset="-127"/>
+              </a:rPr>
+              <a:t/>
+            </a:r>
             <a:br>
               <a:rPr lang="en-US" altLang="ko-KR" dirty="0">
                 <a:latin typeface="메이플스토리" panose="02000300000000000000" pitchFamily="2" charset="-127"/>
@@ -13069,7 +13179,7 @@
         </p:nvGraphicFramePr>
         <p:xfrm>
           <a:off x="838200" y="2539103"/>
-          <a:ext cx="10515600" cy="1483360"/>
+          <a:ext cx="10515600" cy="2021840"/>
         </p:xfrm>
         <a:graphic>
           <a:graphicData uri="http://schemas.openxmlformats.org/drawingml/2006/table">
@@ -13388,7 +13498,7 @@
         </p:nvSpPr>
         <p:spPr>
           <a:xfrm>
-            <a:off x="838200" y="4192593"/>
+            <a:off x="1217763" y="4191611"/>
             <a:ext cx="2786340" cy="369332"/>
           </a:xfrm>
           <a:prstGeom prst="rect">
@@ -13919,6 +14029,15 @@
               </a:rPr>
               <a:t>강의 클릭</a:t>
             </a:r>
+            <a:r>
+              <a:rPr lang="en-US" altLang="ko-KR" dirty="0">
+                <a:solidFill>
+                  <a:srgbClr val="212529"/>
+                </a:solidFill>
+                <a:latin typeface="+mn-ea"/>
+              </a:rPr>
+              <a:t/>
+            </a:r>
             <a:br>
               <a:rPr lang="en-US" altLang="ko-KR" dirty="0">
                 <a:solidFill>
@@ -14604,6 +14723,10 @@
                 </a:solidFill>
               </a:rPr>
               <a:t>정적 타입 언어</a:t>
+            </a:r>
+            <a:r>
+              <a:rPr lang="en-US" altLang="ko-KR" dirty="0"/>
+              <a:t/>
             </a:r>
             <a:br>
               <a:rPr lang="en-US" altLang="ko-KR" dirty="0"/>
@@ -16310,7 +16433,7 @@
         <p:spPr/>
         <p:txBody>
           <a:bodyPr>
-            <a:normAutofit/>
+            <a:normAutofit lnSpcReduction="10000"/>
           </a:bodyPr>
           <a:lstStyle/>
           <a:p>

</xml_diff>

<commit_message>
study(0821) : Ts & Ts_React
</commit_message>
<xml_diff>
--- a/material/[SeSAC_YDP_6] 32_1_TypeScript.pptx
+++ b/material/[SeSAC_YDP_6] 32_1_TypeScript.pptx
@@ -223,7 +223,7 @@
           <a:p>
             <a:fld id="{86F0F02C-F923-483B-B7AF-E4D1E093BA0E}" type="datetimeFigureOut">
               <a:rPr lang="ko-KR" altLang="en-US" smtClean="0"/>
-              <a:t>2024-08-20</a:t>
+              <a:t>2024-08-21</a:t>
             </a:fld>
             <a:endParaRPr lang="ko-KR" altLang="en-US"/>
           </a:p>
@@ -2152,6 +2152,139 @@
         <p:txBody>
           <a:bodyPr/>
           <a:lstStyle/>
+          <a:p>
+            <a:r>
+              <a:rPr lang="en-US" altLang="ko-KR" b="1" dirty="0"/>
+              <a:t>interface</a:t>
+            </a:r>
+            <a:r>
+              <a:rPr lang="en-US" altLang="ko-KR" dirty="0"/>
+              <a:t>: </a:t>
+            </a:r>
+            <a:r>
+              <a:rPr lang="ko-KR" altLang="en-US" dirty="0"/>
+              <a:t>주로 객체의 형태를 정의하고</a:t>
+            </a:r>
+            <a:r>
+              <a:rPr lang="en-US" altLang="ko-KR" dirty="0"/>
+              <a:t>, </a:t>
+            </a:r>
+            <a:r>
+              <a:rPr lang="ko-KR" altLang="en-US" dirty="0"/>
+              <a:t>클래스와의 상호작용이나 확장이 필요한 경우 사용</a:t>
+            </a:r>
+            <a:r>
+              <a:rPr lang="en-US" altLang="ko-KR" dirty="0"/>
+              <a:t>.</a:t>
+            </a:r>
+          </a:p>
+          <a:p>
+            <a:r>
+              <a:rPr lang="ko-KR" altLang="en-US" dirty="0"/>
+              <a:t>기본적으로 객체의 형태를 정의</a:t>
+            </a:r>
+            <a:endParaRPr lang="en-US" altLang="ko-KR" dirty="0"/>
+          </a:p>
+          <a:p>
+            <a:r>
+              <a:rPr lang="en-US" altLang="ko-KR" dirty="0"/>
+              <a:t>interface</a:t>
+            </a:r>
+            <a:r>
+              <a:rPr lang="ko-KR" altLang="en-US" dirty="0"/>
+              <a:t>는 확장이 용이합니다</a:t>
+            </a:r>
+            <a:r>
+              <a:rPr lang="en-US" altLang="ko-KR" dirty="0"/>
+              <a:t>. </a:t>
+            </a:r>
+            <a:r>
+              <a:rPr lang="ko-KR" altLang="en-US" dirty="0"/>
+              <a:t>하나의 인터페이스를 다른 인터페이스로 확장할 수 있어</a:t>
+            </a:r>
+            <a:r>
+              <a:rPr lang="en-US" altLang="ko-KR" dirty="0"/>
+              <a:t>, </a:t>
+            </a:r>
+            <a:r>
+              <a:rPr lang="ko-KR" altLang="en-US" dirty="0"/>
+              <a:t>기본 인터페이스에 새로운 속성을 추가하거나 기존의 인터페이스를 기반으로 하는 새로운 인터페이스를 만들 때 유용합니다</a:t>
+            </a:r>
+            <a:r>
+              <a:rPr lang="en-US" altLang="ko-KR"/>
+              <a:t>.</a:t>
+            </a:r>
+          </a:p>
+          <a:p>
+            <a:endParaRPr lang="en-US" altLang="ko-KR" dirty="0"/>
+          </a:p>
+          <a:p>
+            <a:r>
+              <a:rPr lang="en-US" altLang="ko-KR" b="1" dirty="0"/>
+              <a:t>type</a:t>
+            </a:r>
+            <a:r>
+              <a:rPr lang="en-US" altLang="ko-KR" dirty="0"/>
+              <a:t>: </a:t>
+            </a:r>
+            <a:r>
+              <a:rPr lang="ko-KR" altLang="en-US" dirty="0"/>
+              <a:t>유니온 타입</a:t>
+            </a:r>
+            <a:r>
+              <a:rPr lang="en-US" altLang="ko-KR" dirty="0"/>
+              <a:t>, </a:t>
+            </a:r>
+            <a:r>
+              <a:rPr lang="ko-KR" altLang="en-US" dirty="0" err="1"/>
+              <a:t>튜플</a:t>
+            </a:r>
+            <a:r>
+              <a:rPr lang="en-US" altLang="ko-KR" dirty="0"/>
+              <a:t>, </a:t>
+            </a:r>
+            <a:r>
+              <a:rPr lang="ko-KR" altLang="en-US" dirty="0" err="1"/>
+              <a:t>맵핑된</a:t>
+            </a:r>
+            <a:r>
+              <a:rPr lang="ko-KR" altLang="en-US" dirty="0"/>
+              <a:t> 타입 등 보다 복잡한 타입 정의나 기존 타입을 조합할 때 사용</a:t>
+            </a:r>
+            <a:r>
+              <a:rPr lang="en-US" altLang="ko-KR" dirty="0"/>
+              <a:t>.</a:t>
+            </a:r>
+          </a:p>
+          <a:p>
+            <a:r>
+              <a:rPr lang="ko-KR" altLang="en-US" b="1" dirty="0"/>
+              <a:t>유니온 타입</a:t>
+            </a:r>
+            <a:r>
+              <a:rPr lang="en-US" altLang="ko-KR" dirty="0"/>
+              <a:t>: type</a:t>
+            </a:r>
+            <a:r>
+              <a:rPr lang="ko-KR" altLang="en-US" dirty="0"/>
+              <a:t>을 사용하면 유니온 타입을 정의할 수 있습니다</a:t>
+            </a:r>
+            <a:r>
+              <a:rPr lang="en-US" altLang="ko-KR" dirty="0"/>
+              <a:t>. </a:t>
+            </a:r>
+            <a:r>
+              <a:rPr lang="ko-KR" altLang="en-US" dirty="0"/>
+              <a:t>특정 타입들이 합쳐진 새로운 타입을 정의할 때 유용합니다</a:t>
+            </a:r>
+            <a:r>
+              <a:rPr lang="en-US" altLang="ko-KR" dirty="0"/>
+              <a:t>.</a:t>
+            </a:r>
+          </a:p>
+          <a:p>
+            <a:endParaRPr lang="en-US" altLang="ko-KR" dirty="0"/>
+          </a:p>
           <a:p>
             <a:endParaRPr lang="ko-KR" altLang="en-US" dirty="0"/>
           </a:p>
@@ -8072,16 +8205,6 @@
             </a:endParaRPr>
           </a:p>
           <a:p>
-            <a:r>
-              <a:rPr lang="en-US" altLang="ko-KR" b="0" dirty="0">
-                <a:solidFill>
-                  <a:srgbClr val="A9B1D6"/>
-                </a:solidFill>
-                <a:effectLst/>
-                <a:latin typeface="Consolas" panose="020B0609020204030204" pitchFamily="49" charset="0"/>
-              </a:rPr>
-              <a:t/>
-            </a:r>
             <a:br>
               <a:rPr lang="en-US" altLang="ko-KR" b="0" dirty="0">
                 <a:solidFill>
@@ -10595,7 +10718,7 @@
           <a:p>
             <a:fld id="{0F78D9C4-20C1-4B15-A116-16DC77AD9A1E}" type="datetime1">
               <a:rPr lang="ko-KR" altLang="en-US" smtClean="0"/>
-              <a:t>2024-08-20</a:t>
+              <a:t>2024-08-21</a:t>
             </a:fld>
             <a:endParaRPr lang="ko-KR" altLang="en-US"/>
           </a:p>
@@ -10938,15 +11061,6 @@
                 <a:latin typeface="+mn-ea"/>
               </a:rPr>
               <a:t>강의 클릭</a:t>
-            </a:r>
-            <a:r>
-              <a:rPr lang="en-US" altLang="ko-KR" dirty="0">
-                <a:solidFill>
-                  <a:srgbClr val="212529"/>
-                </a:solidFill>
-                <a:latin typeface="+mn-ea"/>
-              </a:rPr>
-              <a:t/>
             </a:r>
             <a:br>
               <a:rPr lang="en-US" altLang="ko-KR" dirty="0">
@@ -12949,13 +13063,6 @@
               </a:rPr>
               <a:t>되는 것</a:t>
             </a:r>
-            <a:r>
-              <a:rPr lang="en-US" altLang="ko-KR" dirty="0">
-                <a:latin typeface="메이플스토리" panose="02000300000000000000" pitchFamily="2" charset="-127"/>
-                <a:ea typeface="메이플스토리" panose="02000300000000000000" pitchFamily="2" charset="-127"/>
-              </a:rPr>
-              <a:t/>
-            </a:r>
             <a:br>
               <a:rPr lang="en-US" altLang="ko-KR" dirty="0">
                 <a:latin typeface="메이플스토리" panose="02000300000000000000" pitchFamily="2" charset="-127"/>
@@ -13179,7 +13286,7 @@
         </p:nvGraphicFramePr>
         <p:xfrm>
           <a:off x="838200" y="2539103"/>
-          <a:ext cx="10515600" cy="2021840"/>
+          <a:ext cx="10515600" cy="1483360"/>
         </p:xfrm>
         <a:graphic>
           <a:graphicData uri="http://schemas.openxmlformats.org/drawingml/2006/table">
@@ -13685,7 +13792,7 @@
           <a:p>
             <a:fld id="{0F78D9C4-20C1-4B15-A116-16DC77AD9A1E}" type="datetime1">
               <a:rPr lang="ko-KR" altLang="en-US" smtClean="0"/>
-              <a:t>2024-08-20</a:t>
+              <a:t>2024-08-21</a:t>
             </a:fld>
             <a:endParaRPr lang="ko-KR" altLang="en-US"/>
           </a:p>
@@ -14028,15 +14135,6 @@
                 <a:latin typeface="+mn-ea"/>
               </a:rPr>
               <a:t>강의 클릭</a:t>
-            </a:r>
-            <a:r>
-              <a:rPr lang="en-US" altLang="ko-KR" dirty="0">
-                <a:solidFill>
-                  <a:srgbClr val="212529"/>
-                </a:solidFill>
-                <a:latin typeface="+mn-ea"/>
-              </a:rPr>
-              <a:t/>
             </a:r>
             <a:br>
               <a:rPr lang="en-US" altLang="ko-KR" dirty="0">
@@ -14723,10 +14821,6 @@
                 </a:solidFill>
               </a:rPr>
               <a:t>정적 타입 언어</a:t>
-            </a:r>
-            <a:r>
-              <a:rPr lang="en-US" altLang="ko-KR" dirty="0"/>
-              <a:t/>
             </a:r>
             <a:br>
               <a:rPr lang="en-US" altLang="ko-KR" dirty="0"/>

</xml_diff>